<commit_message>
docs: clarify progress slides with simple bullet points
</commit_message>
<xml_diff>
--- a/docs/presentation/COE444_Progress_Report_Final.pptx
+++ b/docs/presentation/COE444_Progress_Report_Final.pptx
@@ -2,17 +2,17 @@
 <file path=ppt/presentation.xml><?xml version="1.0" encoding="utf-8"?>
 <p:presentation xmlns:p="http://schemas.openxmlformats.org/presentationml/2006/main">
   <p:sldMasterIdLst>
-    <p:sldMasterId xmlns:r="http://schemas.openxmlformats.org/officeDocument/2006/relationships" id="2147483648" r:id="R70a378df7ac0475f"/>
+    <p:sldMasterId xmlns:r="http://schemas.openxmlformats.org/officeDocument/2006/relationships" id="2147483648" r:id="Rb3d1da4fb7164430"/>
   </p:sldMasterIdLst>
   <p:notesMasterIdLst>
-    <p:notesMasterId xmlns:r="http://schemas.openxmlformats.org/officeDocument/2006/relationships" r:id="R137275f153734463"/>
+    <p:notesMasterId xmlns:r="http://schemas.openxmlformats.org/officeDocument/2006/relationships" r:id="Rda91c7db7f444de7"/>
   </p:notesMasterIdLst>
   <p:sldIdLst>
-    <p:sldId xmlns:r="http://schemas.openxmlformats.org/officeDocument/2006/relationships" id="256" r:id="R265ce9279d544879"/>
-    <p:sldId xmlns:r="http://schemas.openxmlformats.org/officeDocument/2006/relationships" id="257" r:id="Rd1ad5be034e0444e"/>
-    <p:sldId xmlns:r="http://schemas.openxmlformats.org/officeDocument/2006/relationships" id="258" r:id="R9d2bd871a43a431b"/>
-    <p:sldId xmlns:r="http://schemas.openxmlformats.org/officeDocument/2006/relationships" id="259" r:id="R5fa22e7c034b4551"/>
-    <p:sldId xmlns:r="http://schemas.openxmlformats.org/officeDocument/2006/relationships" id="260" r:id="R40b46a9352754f2e"/>
+    <p:sldId xmlns:r="http://schemas.openxmlformats.org/officeDocument/2006/relationships" id="256" r:id="R5a9d3c81f76e4126"/>
+    <p:sldId xmlns:r="http://schemas.openxmlformats.org/officeDocument/2006/relationships" id="257" r:id="R84f118e5188b4936"/>
+    <p:sldId xmlns:r="http://schemas.openxmlformats.org/officeDocument/2006/relationships" id="258" r:id="R6dc3cf03af3e4004"/>
+    <p:sldId xmlns:r="http://schemas.openxmlformats.org/officeDocument/2006/relationships" id="259" r:id="R239a3dfe8c2e428e"/>
+    <p:sldId xmlns:r="http://schemas.openxmlformats.org/officeDocument/2006/relationships" id="260" r:id="R5ffabd0039d444a2"/>
   </p:sldIdLst>
   <p:sldSz cx="12192000" cy="6858000"/>
   <p:notesSz cx="6858000" cy="9144000"/>
@@ -940,7 +940,7 @@
   </p:cSld>
   <p:clrMap bg1="lt1" tx1="dk1" bg2="lt2" tx2="dk2" accent1="accent1" accent2="accent2" accent3="accent3" accent4="accent4" accent5="accent5" accent6="accent6" hlink="hlink" folHlink="folHlink"/>
   <p:sldLayoutIdLst>
-    <p:sldLayoutId xmlns:r="http://schemas.openxmlformats.org/officeDocument/2006/relationships" id="2147483649" r:id="Rce72ea840a2147c5"/>
+    <p:sldLayoutId xmlns:r="http://schemas.openxmlformats.org/officeDocument/2006/relationships" id="2147483649" r:id="R2f49a5de85694e21"/>
   </p:sldLayoutIdLst>
   <p:hf sldNum="0" hdr="0" ftr="0" dt="0"/>
   <p:txStyles>
@@ -1511,7 +1511,7 @@
           <p:cNvPr id="2" name="Shape 0">
             <a:extLst xmlns:a="http://schemas.openxmlformats.org/drawingml/2006/main">
               <a:ext uri="{FF2B5EF4-FFF2-40B4-BE49-F238E27FC236}">
-                <a16:creationId xmlns:a16="http://schemas.microsoft.com/office/drawing/2014/main" id="{DF8400B6-0449-459F-BF07-73AD8ED86F34}"/>
+                <a16:creationId xmlns:a16="http://schemas.microsoft.com/office/drawing/2014/main" id="{AE94D3B1-64D1-4B17-8F06-89719203BD28}"/>
               </a:ext>
             </a:extLst>
           </p:cNvPr>
@@ -1538,7 +1538,7 @@
           <p:cNvPr id="3" name="Text 1">
             <a:extLst xmlns:a="http://schemas.openxmlformats.org/drawingml/2006/main">
               <a:ext uri="{FF2B5EF4-FFF2-40B4-BE49-F238E27FC236}">
-                <a16:creationId xmlns:a16="http://schemas.microsoft.com/office/drawing/2014/main" id="{89AEE735-7A03-49D0-B26A-49FFDA591D58}"/>
+                <a16:creationId xmlns:a16="http://schemas.microsoft.com/office/drawing/2014/main" id="{AB84AA32-CB68-429C-884F-CAB525138E71}"/>
               </a:ext>
             </a:extLst>
           </p:cNvPr>
@@ -1682,7 +1682,7 @@
           <p:cNvPr id="4" name="Text 2">
             <a:extLst xmlns:a="http://schemas.openxmlformats.org/drawingml/2006/main">
               <a:ext uri="{FF2B5EF4-FFF2-40B4-BE49-F238E27FC236}">
-                <a16:creationId xmlns:a16="http://schemas.microsoft.com/office/drawing/2014/main" id="{B30EC614-F94D-4124-B781-AD66DC77CC96}"/>
+                <a16:creationId xmlns:a16="http://schemas.microsoft.com/office/drawing/2014/main" id="{6FC8A675-8AF0-4965-9E6C-ADC86614E1E3}"/>
               </a:ext>
             </a:extLst>
           </p:cNvPr>
@@ -1728,7 +1728,7 @@
           <p:cNvPr id="5" name="Text 3">
             <a:extLst xmlns:a="http://schemas.openxmlformats.org/drawingml/2006/main">
               <a:ext uri="{FF2B5EF4-FFF2-40B4-BE49-F238E27FC236}">
-                <a16:creationId xmlns:a16="http://schemas.microsoft.com/office/drawing/2014/main" id="{70FB2AF9-F8F1-441E-AD20-82781B3C2C66}"/>
+                <a16:creationId xmlns:a16="http://schemas.microsoft.com/office/drawing/2014/main" id="{E9AB7974-47AA-45D0-B950-39AC38C8D65E}"/>
               </a:ext>
             </a:extLst>
           </p:cNvPr>
@@ -1774,7 +1774,7 @@
           <p:cNvPr id="6" name="Text 4">
             <a:extLst xmlns:a="http://schemas.openxmlformats.org/drawingml/2006/main">
               <a:ext uri="{FF2B5EF4-FFF2-40B4-BE49-F238E27FC236}">
-                <a16:creationId xmlns:a16="http://schemas.microsoft.com/office/drawing/2014/main" id="{06A8F4B8-7874-477A-AE95-3E3120E7A762}"/>
+                <a16:creationId xmlns:a16="http://schemas.microsoft.com/office/drawing/2014/main" id="{E28BE37A-A5D1-4DD8-80C0-C616DFB596AE}"/>
               </a:ext>
             </a:extLst>
           </p:cNvPr>
@@ -1820,7 +1820,7 @@
           <p:cNvPr id="7" name="Text 5">
             <a:extLst xmlns:a="http://schemas.openxmlformats.org/drawingml/2006/main">
               <a:ext uri="{FF2B5EF4-FFF2-40B4-BE49-F238E27FC236}">
-                <a16:creationId xmlns:a16="http://schemas.microsoft.com/office/drawing/2014/main" id="{E8BE516D-1E92-41BF-8652-82AF03DD0B07}"/>
+                <a16:creationId xmlns:a16="http://schemas.microsoft.com/office/drawing/2014/main" id="{A2D56E62-6295-4579-80D7-9338B2981BE5}"/>
               </a:ext>
             </a:extLst>
           </p:cNvPr>
@@ -1866,7 +1866,7 @@
           <p:cNvPr id="8" name="Text 6">
             <a:extLst xmlns:a="http://schemas.openxmlformats.org/drawingml/2006/main">
               <a:ext uri="{FF2B5EF4-FFF2-40B4-BE49-F238E27FC236}">
-                <a16:creationId xmlns:a16="http://schemas.microsoft.com/office/drawing/2014/main" id="{793A6A2C-679C-48AC-BF2A-F929590CE135}"/>
+                <a16:creationId xmlns:a16="http://schemas.microsoft.com/office/drawing/2014/main" id="{F1138344-5AB7-4D50-BA53-A89AF16D2E6D}"/>
               </a:ext>
             </a:extLst>
           </p:cNvPr>
@@ -2010,7 +2010,7 @@
           <p:cNvPr id="9" name="Text 7">
             <a:extLst xmlns:a="http://schemas.openxmlformats.org/drawingml/2006/main">
               <a:ext uri="{FF2B5EF4-FFF2-40B4-BE49-F238E27FC236}">
-                <a16:creationId xmlns:a16="http://schemas.microsoft.com/office/drawing/2014/main" id="{6EA5CCC6-88F8-4922-B6A5-EB712C6299A5}"/>
+                <a16:creationId xmlns:a16="http://schemas.microsoft.com/office/drawing/2014/main" id="{0139DA1A-A428-4FD0-A655-BEB95595CBFB}"/>
               </a:ext>
             </a:extLst>
           </p:cNvPr>
@@ -2056,7 +2056,7 @@
           <p:cNvPr id="10" name="Text 8">
             <a:extLst xmlns:a="http://schemas.openxmlformats.org/drawingml/2006/main">
               <a:ext uri="{FF2B5EF4-FFF2-40B4-BE49-F238E27FC236}">
-                <a16:creationId xmlns:a16="http://schemas.microsoft.com/office/drawing/2014/main" id="{4821F314-A1E7-44DD-A780-31BB855C84E4}"/>
+                <a16:creationId xmlns:a16="http://schemas.microsoft.com/office/drawing/2014/main" id="{FC98CE25-F8D3-47FC-83C5-6716A70B7950}"/>
               </a:ext>
             </a:extLst>
           </p:cNvPr>
@@ -2102,7 +2102,7 @@
           <p:cNvPr id="11" name="Text 9">
             <a:extLst xmlns:a="http://schemas.openxmlformats.org/drawingml/2006/main">
               <a:ext uri="{FF2B5EF4-FFF2-40B4-BE49-F238E27FC236}">
-                <a16:creationId xmlns:a16="http://schemas.microsoft.com/office/drawing/2014/main" id="{D954B445-82C4-4BD8-A02D-7E523CCD2903}"/>
+                <a16:creationId xmlns:a16="http://schemas.microsoft.com/office/drawing/2014/main" id="{F04ADB8D-F47B-47DB-A0C6-409132C07A14}"/>
               </a:ext>
             </a:extLst>
           </p:cNvPr>
@@ -2148,7 +2148,7 @@
           <p:cNvPr id="12" name="Text 10">
             <a:extLst xmlns:a="http://schemas.openxmlformats.org/drawingml/2006/main">
               <a:ext uri="{FF2B5EF4-FFF2-40B4-BE49-F238E27FC236}">
-                <a16:creationId xmlns:a16="http://schemas.microsoft.com/office/drawing/2014/main" id="{0910AB33-8BD1-448C-9F44-985F959746CA}"/>
+                <a16:creationId xmlns:a16="http://schemas.microsoft.com/office/drawing/2014/main" id="{A18CE035-54BB-4E61-9BA6-0A58A889A746}"/>
               </a:ext>
             </a:extLst>
           </p:cNvPr>
@@ -2194,7 +2194,7 @@
           <p:cNvPr id="13" name="Text 11">
             <a:extLst xmlns:a="http://schemas.openxmlformats.org/drawingml/2006/main">
               <a:ext uri="{FF2B5EF4-FFF2-40B4-BE49-F238E27FC236}">
-                <a16:creationId xmlns:a16="http://schemas.microsoft.com/office/drawing/2014/main" id="{7778FD06-2696-41B2-AB87-F0B6621CD4D9}"/>
+                <a16:creationId xmlns:a16="http://schemas.microsoft.com/office/drawing/2014/main" id="{FB5168AC-9125-4AB3-B56B-2E29A41DA50E}"/>
               </a:ext>
             </a:extLst>
           </p:cNvPr>
@@ -2240,7 +2240,7 @@
           <p:cNvPr id="14" name="Text 12">
             <a:extLst xmlns:a="http://schemas.openxmlformats.org/drawingml/2006/main">
               <a:ext uri="{FF2B5EF4-FFF2-40B4-BE49-F238E27FC236}">
-                <a16:creationId xmlns:a16="http://schemas.microsoft.com/office/drawing/2014/main" id="{201B333F-28CB-43DD-B748-7D66AB6C8031}"/>
+                <a16:creationId xmlns:a16="http://schemas.microsoft.com/office/drawing/2014/main" id="{F7A3DA0A-3B74-41F0-9414-8C1AB0FDAA37}"/>
               </a:ext>
             </a:extLst>
           </p:cNvPr>
@@ -2286,7 +2286,7 @@
           <p:cNvPr id="15" name="Text 13">
             <a:extLst xmlns:a="http://schemas.openxmlformats.org/drawingml/2006/main">
               <a:ext uri="{FF2B5EF4-FFF2-40B4-BE49-F238E27FC236}">
-                <a16:creationId xmlns:a16="http://schemas.microsoft.com/office/drawing/2014/main" id="{8C7C6EE1-7DEB-4758-9AFF-6C677C945B4B}"/>
+                <a16:creationId xmlns:a16="http://schemas.microsoft.com/office/drawing/2014/main" id="{F932886E-02D1-4AA0-8D68-E134783B7860}"/>
               </a:ext>
             </a:extLst>
           </p:cNvPr>
@@ -2332,7 +2332,7 @@
           <p:cNvPr id="16" name="Text 14">
             <a:extLst xmlns:a="http://schemas.openxmlformats.org/drawingml/2006/main">
               <a:ext uri="{FF2B5EF4-FFF2-40B4-BE49-F238E27FC236}">
-                <a16:creationId xmlns:a16="http://schemas.microsoft.com/office/drawing/2014/main" id="{DC1B97D4-FD92-4B9E-AF92-AD0C621EB888}"/>
+                <a16:creationId xmlns:a16="http://schemas.microsoft.com/office/drawing/2014/main" id="{00CF47CB-2E0D-4A1F-8202-746B039FEDB8}"/>
               </a:ext>
             </a:extLst>
           </p:cNvPr>
@@ -2376,7 +2376,7 @@
     </p:spTree>
     <p:extLst>
       <p:ext uri="{BB962C8B-B14F-4D97-AF65-F5344CB8AC3E}">
-        <p14:creationId xmlns:p14="http://schemas.microsoft.com/office/powerpoint/2010/main" val="1783756700"/>
+        <p14:creationId xmlns:p14="http://schemas.microsoft.com/office/powerpoint/2010/main" val="835945727"/>
       </p:ext>
     </p:extLst>
   </p:cSld>
@@ -2407,7 +2407,7 @@
           <p:cNvPr id="2" name="Text 0">
             <a:extLst xmlns:a="http://schemas.openxmlformats.org/drawingml/2006/main">
               <a:ext uri="{FF2B5EF4-FFF2-40B4-BE49-F238E27FC236}">
-                <a16:creationId xmlns:a16="http://schemas.microsoft.com/office/drawing/2014/main" id="{0D17828D-9DA5-4587-B7E7-3045D8747FE8}"/>
+                <a16:creationId xmlns:a16="http://schemas.microsoft.com/office/drawing/2014/main" id="{F140F9A6-9584-44A5-8188-5222A866A01B}"/>
               </a:ext>
             </a:extLst>
           </p:cNvPr>
@@ -2453,7 +2453,7 @@
           <p:cNvPr id="3" name="Text 1">
             <a:extLst xmlns:a="http://schemas.openxmlformats.org/drawingml/2006/main">
               <a:ext uri="{FF2B5EF4-FFF2-40B4-BE49-F238E27FC236}">
-                <a16:creationId xmlns:a16="http://schemas.microsoft.com/office/drawing/2014/main" id="{E8E7D34B-3AF4-4581-B991-B6A3E8DD0074}"/>
+                <a16:creationId xmlns:a16="http://schemas.microsoft.com/office/drawing/2014/main" id="{437BAB68-11DC-4FE0-B498-131ADDF4FE25}"/>
               </a:ext>
             </a:extLst>
           </p:cNvPr>
@@ -2499,7 +2499,7 @@
           <p:cNvPr id="4" name="Text 2">
             <a:extLst xmlns:a="http://schemas.openxmlformats.org/drawingml/2006/main">
               <a:ext uri="{FF2B5EF4-FFF2-40B4-BE49-F238E27FC236}">
-                <a16:creationId xmlns:a16="http://schemas.microsoft.com/office/drawing/2014/main" id="{C736904F-D6CE-4216-AEFD-258CD45F4B00}"/>
+                <a16:creationId xmlns:a16="http://schemas.microsoft.com/office/drawing/2014/main" id="{5E55BF23-D45A-4E3B-803A-190D5324CBB3}"/>
               </a:ext>
             </a:extLst>
           </p:cNvPr>
@@ -2545,7 +2545,7 @@
           <p:cNvPr id="5" name="Shape 3">
             <a:extLst xmlns:a="http://schemas.openxmlformats.org/drawingml/2006/main">
               <a:ext uri="{FF2B5EF4-FFF2-40B4-BE49-F238E27FC236}">
-                <a16:creationId xmlns:a16="http://schemas.microsoft.com/office/drawing/2014/main" id="{74795ABD-1D2C-40ED-AD69-39EEDB2E17AD}"/>
+                <a16:creationId xmlns:a16="http://schemas.microsoft.com/office/drawing/2014/main" id="{A2272013-BCBF-439B-AA89-C64630DA8863}"/>
               </a:ext>
             </a:extLst>
           </p:cNvPr>
@@ -2572,7 +2572,7 @@
           <p:cNvPr id="6" name="Text 4">
             <a:extLst xmlns:a="http://schemas.openxmlformats.org/drawingml/2006/main">
               <a:ext uri="{FF2B5EF4-FFF2-40B4-BE49-F238E27FC236}">
-                <a16:creationId xmlns:a16="http://schemas.microsoft.com/office/drawing/2014/main" id="{5B6E0E35-CE7E-4C58-BF89-ADBF210D6F1A}"/>
+                <a16:creationId xmlns:a16="http://schemas.microsoft.com/office/drawing/2014/main" id="{F59BC3A1-22F9-4025-A18D-7673DC834B74}"/>
               </a:ext>
             </a:extLst>
           </p:cNvPr>
@@ -2607,7 +2607,7 @@
                 <a:ea typeface="Calibri"/>
                 <a:cs typeface="Calibri"/>
               </a:rPr>
-              <a:t>PROBLEM AND REFINEMENTS</a:t>
+              <a:t>THE PROBLEM WE ARE TESTING</a:t>
             </a:r>
             <a:endParaRPr sz="1100"/>
           </a:p>
@@ -2618,7 +2618,7 @@
           <p:cNvPr id="9" name="Text 7">
             <a:extLst xmlns:a="http://schemas.openxmlformats.org/drawingml/2006/main">
               <a:ext uri="{FF2B5EF4-FFF2-40B4-BE49-F238E27FC236}">
-                <a16:creationId xmlns:a16="http://schemas.microsoft.com/office/drawing/2014/main" id="{180912ED-31DF-48FB-A07F-3EA9F6B9B8F7}"/>
+                <a16:creationId xmlns:a16="http://schemas.microsoft.com/office/drawing/2014/main" id="{E7B8BCC2-E36D-40EB-B1AF-06E3827E0DD1}"/>
               </a:ext>
             </a:extLst>
           </p:cNvPr>
@@ -2664,7 +2664,7 @@
           <p:cNvPr id="10" name="Text 8">
             <a:extLst xmlns:a="http://schemas.openxmlformats.org/drawingml/2006/main">
               <a:ext uri="{FF2B5EF4-FFF2-40B4-BE49-F238E27FC236}">
-                <a16:creationId xmlns:a16="http://schemas.microsoft.com/office/drawing/2014/main" id="{C7548D54-59BE-4DD0-9886-74747849DAD5}"/>
+                <a16:creationId xmlns:a16="http://schemas.microsoft.com/office/drawing/2014/main" id="{A7FEF28B-4C20-4F2D-86E9-C9DA16694C14}"/>
               </a:ext>
             </a:extLst>
           </p:cNvPr>
@@ -2710,7 +2710,7 @@
           <p:cNvPr id="11" name="">
             <a:extLst xmlns:a="http://schemas.openxmlformats.org/drawingml/2006/main">
               <a:ext uri="{FF2B5EF4-FFF2-40B4-BE49-F238E27FC236}">
-                <a16:creationId xmlns:a16="http://schemas.microsoft.com/office/drawing/2014/main" id="{96E562D3-087F-4A00-8FA3-D43A77567AA8}"/>
+                <a16:creationId xmlns:a16="http://schemas.microsoft.com/office/drawing/2014/main" id="{5CB1A334-7984-44BA-A11B-E2D2F780C73D}"/>
               </a:ext>
             </a:extLst>
           </p:cNvPr>
@@ -2722,7 +2722,7 @@
         <p:spPr>
           <a:xfrm xmlns:a="http://schemas.openxmlformats.org/drawingml/2006/main">
             <a:off x="960120" y="2009775"/>
-            <a:ext cx="10271474" cy="704850"/>
+            <a:ext cx="10271474" cy="1714500"/>
           </a:xfrm>
           <a:prstGeom xmlns:a="http://schemas.openxmlformats.org/drawingml/2006/main" prst="rect">
             <a:avLst/>
@@ -2733,73 +2733,75 @@
           </a:ln>
         </p:spPr>
         <p:txBody>
-          <a:bodyPr xmlns:a="http://schemas.openxmlformats.org/drawingml/2006/main" lIns="0" tIns="0" rIns="0" bIns="0"/>
+          <a:bodyPr xmlns:a="http://schemas.openxmlformats.org/drawingml/2006/main" lIns="0" tIns="0" rIns="0" bIns="0">
+            <a:noAutofit/>
+          </a:bodyPr>
           <a:lstStyle xmlns:a="http://schemas.openxmlformats.org/drawingml/2006/main">
             <a:defPPr>
-              <a:defRPr sz="1725">
+              <a:defRPr sz="1575">
                 <a:solidFill>
                   <a:srgbClr val="1A1A1A"/>
                 </a:solidFill>
               </a:defRPr>
             </a:defPPr>
             <a:lvl1pPr>
-              <a:defRPr sz="1725">
+              <a:defRPr sz="1575">
                 <a:solidFill>
                   <a:srgbClr val="1A1A1A"/>
                 </a:solidFill>
               </a:defRPr>
             </a:lvl1pPr>
             <a:lvl2pPr>
-              <a:defRPr sz="1725">
+              <a:defRPr sz="1575">
                 <a:solidFill>
                   <a:srgbClr val="1A1A1A"/>
                 </a:solidFill>
               </a:defRPr>
             </a:lvl2pPr>
             <a:lvl3pPr>
-              <a:defRPr sz="1725">
+              <a:defRPr sz="1575">
                 <a:solidFill>
                   <a:srgbClr val="1A1A1A"/>
                 </a:solidFill>
               </a:defRPr>
             </a:lvl3pPr>
             <a:lvl4pPr>
-              <a:defRPr sz="1725">
+              <a:defRPr sz="1575">
                 <a:solidFill>
                   <a:srgbClr val="1A1A1A"/>
                 </a:solidFill>
               </a:defRPr>
             </a:lvl4pPr>
             <a:lvl5pPr>
-              <a:defRPr sz="1725">
+              <a:defRPr sz="1575">
                 <a:solidFill>
                   <a:srgbClr val="1A1A1A"/>
                 </a:solidFill>
               </a:defRPr>
             </a:lvl5pPr>
             <a:lvl6pPr>
-              <a:defRPr sz="1725">
+              <a:defRPr sz="1575">
                 <a:solidFill>
                   <a:srgbClr val="1A1A1A"/>
                 </a:solidFill>
               </a:defRPr>
             </a:lvl6pPr>
             <a:lvl7pPr>
-              <a:defRPr sz="1725">
+              <a:defRPr sz="1575">
                 <a:solidFill>
                   <a:srgbClr val="1A1A1A"/>
                 </a:solidFill>
               </a:defRPr>
             </a:lvl7pPr>
             <a:lvl8pPr>
-              <a:defRPr sz="1725">
+              <a:defRPr sz="1575">
                 <a:solidFill>
                   <a:srgbClr val="1A1A1A"/>
                 </a:solidFill>
               </a:defRPr>
             </a:lvl8pPr>
             <a:lvl9pPr>
-              <a:defRPr sz="1725">
+              <a:defRPr sz="1575">
                 <a:solidFill>
                   <a:srgbClr val="1A1A1A"/>
                 </a:solidFill>
@@ -2807,184 +2809,97 @@
             </a:lvl9pPr>
           </a:lstStyle>
           <a:p xmlns:a="http://schemas.openxmlformats.org/drawingml/2006/main">
-            <a:pPr>
-              <a:defRPr sz="1725">
+            <a:pPr marL="190500" indent="-101600">
+              <a:spcAft>
+                <a:spcPts val="800"/>
+              </a:spcAft>
+              <a:buChar char="•"/>
+              <a:defRPr sz="1575">
                 <a:solidFill>
                   <a:srgbClr val="1A1A1A"/>
                 </a:solidFill>
               </a:defRPr>
             </a:pPr>
             <a:r>
-              <a:rPr sz="1725">
+              <a:rPr sz="1575">
                 <a:solidFill>
                   <a:srgbClr val="1A1A1A"/>
                 </a:solidFill>
               </a:rPr>
-              <a:t>Our AI agent chooses tools and steps to complete a user’s task.</a:t>
+              <a:t>Our agent chooses tools, reads the results and decides its next step to complete a user’s task.</a:t>
             </a:r>
           </a:p>
           <a:p xmlns:a="http://schemas.openxmlformats.org/drawingml/2006/main">
-            <a:pPr>
-              <a:defRPr sz="1725">
+            <a:pPr marL="190500" indent="-101600">
+              <a:spcAft>
+                <a:spcPts val="800"/>
+              </a:spcAft>
+              <a:buChar char="•"/>
+              <a:defRPr sz="1575">
                 <a:solidFill>
                   <a:srgbClr val="1A1A1A"/>
                 </a:solidFill>
               </a:defRPr>
             </a:pPr>
             <a:r>
-              <a:rPr sz="1725">
+              <a:rPr sz="1575">
                 <a:solidFill>
                   <a:srgbClr val="1A1A1A"/>
                 </a:solidFill>
               </a:rPr>
-              <a:t>An attacker hides instructions in text the agent reads and tries to change its actions.</a:t>
-            </a:r>
-          </a:p>
-        </p:txBody>
-      </p:sp>
-      <p:sp>
-        <p:nvSpPr>
-          <p:cNvPr id="12" name="">
-            <a:extLst xmlns:a="http://schemas.openxmlformats.org/drawingml/2006/main">
-              <a:ext uri="{FF2B5EF4-FFF2-40B4-BE49-F238E27FC236}">
-                <a16:creationId xmlns:a16="http://schemas.microsoft.com/office/drawing/2014/main" id="{09D59C3A-12BB-42EB-8425-323BA2D3B940}"/>
-              </a:ext>
-            </a:extLst>
-          </p:cNvPr>
-          <p:cNvSpPr>
-            <a:spLocks xmlns:a="http://schemas.openxmlformats.org/drawingml/2006/main" noGrp="1"/>
-          </p:cNvSpPr>
-          <p:nvPr/>
-        </p:nvSpPr>
-        <p:spPr>
-          <a:xfrm xmlns:a="http://schemas.openxmlformats.org/drawingml/2006/main">
-            <a:off x="960120" y="2886075"/>
-            <a:ext cx="10271474" cy="704850"/>
-          </a:xfrm>
-          <a:prstGeom xmlns:a="http://schemas.openxmlformats.org/drawingml/2006/main" prst="rect">
-            <a:avLst/>
-          </a:prstGeom>
-          <a:noFill xmlns:a="http://schemas.openxmlformats.org/drawingml/2006/main"/>
-          <a:ln xmlns:a="http://schemas.openxmlformats.org/drawingml/2006/main" w="0">
-            <a:noFill/>
-          </a:ln>
-        </p:spPr>
-        <p:txBody>
-          <a:bodyPr xmlns:a="http://schemas.openxmlformats.org/drawingml/2006/main" lIns="0" tIns="0" rIns="0" bIns="0"/>
-          <a:lstStyle xmlns:a="http://schemas.openxmlformats.org/drawingml/2006/main">
-            <a:defPPr>
-              <a:defRPr sz="1725">
-                <a:solidFill>
-                  <a:srgbClr val="1A1A1A"/>
-                </a:solidFill>
-              </a:defRPr>
-            </a:defPPr>
-            <a:lvl1pPr>
-              <a:defRPr sz="1725">
-                <a:solidFill>
-                  <a:srgbClr val="1A1A1A"/>
-                </a:solidFill>
-              </a:defRPr>
-            </a:lvl1pPr>
-            <a:lvl2pPr>
-              <a:defRPr sz="1725">
-                <a:solidFill>
-                  <a:srgbClr val="1A1A1A"/>
-                </a:solidFill>
-              </a:defRPr>
-            </a:lvl2pPr>
-            <a:lvl3pPr>
-              <a:defRPr sz="1725">
-                <a:solidFill>
-                  <a:srgbClr val="1A1A1A"/>
-                </a:solidFill>
-              </a:defRPr>
-            </a:lvl3pPr>
-            <a:lvl4pPr>
-              <a:defRPr sz="1725">
-                <a:solidFill>
-                  <a:srgbClr val="1A1A1A"/>
-                </a:solidFill>
-              </a:defRPr>
-            </a:lvl4pPr>
-            <a:lvl5pPr>
-              <a:defRPr sz="1725">
-                <a:solidFill>
-                  <a:srgbClr val="1A1A1A"/>
-                </a:solidFill>
-              </a:defRPr>
-            </a:lvl5pPr>
-            <a:lvl6pPr>
-              <a:defRPr sz="1725">
-                <a:solidFill>
-                  <a:srgbClr val="1A1A1A"/>
-                </a:solidFill>
-              </a:defRPr>
-            </a:lvl6pPr>
-            <a:lvl7pPr>
-              <a:defRPr sz="1725">
-                <a:solidFill>
-                  <a:srgbClr val="1A1A1A"/>
-                </a:solidFill>
-              </a:defRPr>
-            </a:lvl7pPr>
-            <a:lvl8pPr>
-              <a:defRPr sz="1725">
-                <a:solidFill>
-                  <a:srgbClr val="1A1A1A"/>
-                </a:solidFill>
-              </a:defRPr>
-            </a:lvl8pPr>
-            <a:lvl9pPr>
-              <a:defRPr sz="1725">
-                <a:solidFill>
-                  <a:srgbClr val="1A1A1A"/>
-                </a:solidFill>
-              </a:defRPr>
-            </a:lvl9pPr>
-          </a:lstStyle>
-          <a:p xmlns:a="http://schemas.openxmlformats.org/drawingml/2006/main">
-            <a:pPr>
-              <a:defRPr sz="1725">
-                <a:solidFill>
-                  <a:srgbClr val="1A1A1A"/>
-                </a:solidFill>
-              </a:defRPr>
-            </a:pPr>
-            <a:r>
-              <a:rPr sz="1725">
-                <a:solidFill>
-                  <a:srgbClr val="1A1A1A"/>
-                </a:solidFill>
-              </a:rPr>
-              <a:t>Example: the user asks for a policy email. A poisoned document tells the agent</a:t>
+              <a:t>An attacker hides instructions in a document the agent finds during that task.</a:t>
             </a:r>
           </a:p>
           <a:p xmlns:a="http://schemas.openxmlformats.org/drawingml/2006/main">
-            <a:pPr>
-              <a:defRPr sz="1725">
+            <a:pPr marL="190500" indent="-101600">
+              <a:spcAft>
+                <a:spcPts val="800"/>
+              </a:spcAft>
+              <a:buChar char="•"/>
+              <a:defRPr sz="1575">
                 <a:solidFill>
                   <a:srgbClr val="1A1A1A"/>
                 </a:solidFill>
               </a:defRPr>
             </a:pPr>
             <a:r>
-              <a:rPr sz="1725">
+              <a:rPr sz="1575">
                 <a:solidFill>
                   <a:srgbClr val="1A1A1A"/>
                 </a:solidFill>
               </a:rPr>
-              <a:t>to copy an attacker. Our goal is to stop that action while keeping the task useful.</a:t>
+              <a:t>Example: the user asks for a policy email, but the document tells the agent to copy an attacker.</a:t>
+            </a:r>
+          </a:p>
+          <a:p xmlns:a="http://schemas.openxmlformats.org/drawingml/2006/main">
+            <a:pPr marL="190500" indent="-101600">
+              <a:spcAft>
+                <a:spcPts val="800"/>
+              </a:spcAft>
+              <a:buChar char="•"/>
+              <a:defRPr sz="1575">
+                <a:solidFill>
+                  <a:srgbClr val="1A1A1A"/>
+                </a:solidFill>
+              </a:defRPr>
+            </a:pPr>
+            <a:r>
+              <a:rPr sz="1575">
+                <a:solidFill>
+                  <a:srgbClr val="1A1A1A"/>
+                </a:solidFill>
+              </a:rPr>
+              <a:t>We test whether our defenses stop the attacker’s action while the agent still helps the user.</a:t>
             </a:r>
           </a:p>
         </p:txBody>
       </p:sp>
       <p:graphicFrame>
         <p:nvGraphicFramePr>
-          <p:cNvPr id="13" name="">
+          <p:cNvPr id="12" name="">
             <a:extLst xmlns:a="http://schemas.openxmlformats.org/drawingml/2006/main">
               <a:ext uri="{FF2B5EF4-FFF2-40B4-BE49-F238E27FC236}">
-                <a16:creationId xmlns:a16="http://schemas.microsoft.com/office/drawing/2014/main" id="{DD0A1B8F-97B6-41D1-8417-61671A374950}"/>
+                <a16:creationId xmlns:a16="http://schemas.microsoft.com/office/drawing/2014/main" id="{CB96BB18-028D-4420-B275-38AA79FB5290}"/>
               </a:ext>
             </a:extLst>
           </p:cNvPr>
@@ -3392,7 +3307,7 @@
     </p:spTree>
     <p:extLst>
       <p:ext uri="{BB962C8B-B14F-4D97-AF65-F5344CB8AC3E}">
-        <p14:creationId xmlns:p14="http://schemas.microsoft.com/office/powerpoint/2010/main" val="1921065667"/>
+        <p14:creationId xmlns:p14="http://schemas.microsoft.com/office/powerpoint/2010/main" val="1101021732"/>
       </p:ext>
     </p:extLst>
   </p:cSld>
@@ -3423,7 +3338,7 @@
           <p:cNvPr id="2" name="Text 0">
             <a:extLst xmlns:a="http://schemas.openxmlformats.org/drawingml/2006/main">
               <a:ext uri="{FF2B5EF4-FFF2-40B4-BE49-F238E27FC236}">
-                <a16:creationId xmlns:a16="http://schemas.microsoft.com/office/drawing/2014/main" id="{8063E416-9C61-479A-9FE6-754AAFC47E2F}"/>
+                <a16:creationId xmlns:a16="http://schemas.microsoft.com/office/drawing/2014/main" id="{F9104FF5-962A-419D-A8A2-DAB095F6D551}"/>
               </a:ext>
             </a:extLst>
           </p:cNvPr>
@@ -3469,7 +3384,7 @@
           <p:cNvPr id="3" name="Text 1">
             <a:extLst xmlns:a="http://schemas.openxmlformats.org/drawingml/2006/main">
               <a:ext uri="{FF2B5EF4-FFF2-40B4-BE49-F238E27FC236}">
-                <a16:creationId xmlns:a16="http://schemas.microsoft.com/office/drawing/2014/main" id="{F2105F84-72F0-41BD-B80D-9B6CFFC10AAF}"/>
+                <a16:creationId xmlns:a16="http://schemas.microsoft.com/office/drawing/2014/main" id="{07273ACB-30C1-412C-866D-0C96238BF131}"/>
               </a:ext>
             </a:extLst>
           </p:cNvPr>
@@ -3515,7 +3430,7 @@
           <p:cNvPr id="4" name="Text 2">
             <a:extLst xmlns:a="http://schemas.openxmlformats.org/drawingml/2006/main">
               <a:ext uri="{FF2B5EF4-FFF2-40B4-BE49-F238E27FC236}">
-                <a16:creationId xmlns:a16="http://schemas.microsoft.com/office/drawing/2014/main" id="{68C58182-B9AA-449A-BB34-A07723BB8B05}"/>
+                <a16:creationId xmlns:a16="http://schemas.microsoft.com/office/drawing/2014/main" id="{DAE136B0-8515-4497-ACAD-99730A18BDD4}"/>
               </a:ext>
             </a:extLst>
           </p:cNvPr>
@@ -3561,7 +3476,7 @@
           <p:cNvPr id="5" name="Shape 3">
             <a:extLst xmlns:a="http://schemas.openxmlformats.org/drawingml/2006/main">
               <a:ext uri="{FF2B5EF4-FFF2-40B4-BE49-F238E27FC236}">
-                <a16:creationId xmlns:a16="http://schemas.microsoft.com/office/drawing/2014/main" id="{098C6221-EF02-43C5-98B5-915D9F1CC56B}"/>
+                <a16:creationId xmlns:a16="http://schemas.microsoft.com/office/drawing/2014/main" id="{BCA4D4AB-D4E9-46F3-813E-E7EBA51408CF}"/>
               </a:ext>
             </a:extLst>
           </p:cNvPr>
@@ -3588,7 +3503,7 @@
           <p:cNvPr id="6" name="Text 4">
             <a:extLst xmlns:a="http://schemas.openxmlformats.org/drawingml/2006/main">
               <a:ext uri="{FF2B5EF4-FFF2-40B4-BE49-F238E27FC236}">
-                <a16:creationId xmlns:a16="http://schemas.microsoft.com/office/drawing/2014/main" id="{05B36A27-0E05-4DEE-87AC-7C67543427C4}"/>
+                <a16:creationId xmlns:a16="http://schemas.microsoft.com/office/drawing/2014/main" id="{9A6191EF-0082-4893-BD06-267D5B6932F0}"/>
               </a:ext>
             </a:extLst>
           </p:cNvPr>
@@ -3623,7 +3538,7 @@
                 <a:ea typeface="Calibri"/>
                 <a:cs typeface="Calibri"/>
               </a:rPr>
-              <a:t>IMPLEMENTATION AND EVIDENCE</a:t>
+              <a:t>WORK COMPLETED SO FAR</a:t>
             </a:r>
             <a:endParaRPr sz="1100"/>
           </a:p>
@@ -3634,7 +3549,7 @@
           <p:cNvPr id="9" name="Text 7">
             <a:extLst xmlns:a="http://schemas.openxmlformats.org/drawingml/2006/main">
               <a:ext uri="{FF2B5EF4-FFF2-40B4-BE49-F238E27FC236}">
-                <a16:creationId xmlns:a16="http://schemas.microsoft.com/office/drawing/2014/main" id="{FFB8CF88-2D91-411C-958A-8BE85BF38B8D}"/>
+                <a16:creationId xmlns:a16="http://schemas.microsoft.com/office/drawing/2014/main" id="{0C864146-F26E-44A9-8000-7E2DAFBC7990}"/>
               </a:ext>
             </a:extLst>
           </p:cNvPr>
@@ -3680,7 +3595,7 @@
           <p:cNvPr id="10" name="Text 8">
             <a:extLst xmlns:a="http://schemas.openxmlformats.org/drawingml/2006/main">
               <a:ext uri="{FF2B5EF4-FFF2-40B4-BE49-F238E27FC236}">
-                <a16:creationId xmlns:a16="http://schemas.microsoft.com/office/drawing/2014/main" id="{B3ADDB78-2973-4983-953F-7E3576F4D0C7}"/>
+                <a16:creationId xmlns:a16="http://schemas.microsoft.com/office/drawing/2014/main" id="{A5F7880C-F964-4462-B3BA-55C7BE719364}"/>
               </a:ext>
             </a:extLst>
           </p:cNvPr>
@@ -3726,7 +3641,7 @@
           <p:cNvPr id="11" name="">
             <a:extLst xmlns:a="http://schemas.openxmlformats.org/drawingml/2006/main">
               <a:ext uri="{FF2B5EF4-FFF2-40B4-BE49-F238E27FC236}">
-                <a16:creationId xmlns:a16="http://schemas.microsoft.com/office/drawing/2014/main" id="{35872F6C-D03E-4ED2-9A5A-3A662673CE24}"/>
+                <a16:creationId xmlns:a16="http://schemas.microsoft.com/office/drawing/2014/main" id="{E51954BB-8252-43B0-AC47-EB3B637C287F}"/>
               </a:ext>
             </a:extLst>
           </p:cNvPr>
@@ -3738,7 +3653,7 @@
         <p:spPr>
           <a:xfrm xmlns:a="http://schemas.openxmlformats.org/drawingml/2006/main">
             <a:off x="960120" y="2009775"/>
-            <a:ext cx="10271474" cy="628650"/>
+            <a:ext cx="10271474" cy="1714500"/>
           </a:xfrm>
           <a:prstGeom xmlns:a="http://schemas.openxmlformats.org/drawingml/2006/main" prst="rect">
             <a:avLst/>
@@ -3749,7 +3664,9 @@
           </a:ln>
         </p:spPr>
         <p:txBody>
-          <a:bodyPr xmlns:a="http://schemas.openxmlformats.org/drawingml/2006/main" lIns="0" tIns="0" rIns="0" bIns="0"/>
+          <a:bodyPr xmlns:a="http://schemas.openxmlformats.org/drawingml/2006/main" lIns="0" tIns="0" rIns="0" bIns="0">
+            <a:noAutofit/>
+          </a:bodyPr>
           <a:lstStyle xmlns:a="http://schemas.openxmlformats.org/drawingml/2006/main">
             <a:defPPr>
               <a:defRPr sz="1575">
@@ -3823,7 +3740,11 @@
             </a:lvl9pPr>
           </a:lstStyle>
           <a:p xmlns:a="http://schemas.openxmlformats.org/drawingml/2006/main">
-            <a:pPr>
+            <a:pPr marL="190500" indent="-101600">
+              <a:spcAft>
+                <a:spcPts val="800"/>
+              </a:spcAft>
+              <a:buChar char="•"/>
               <a:defRPr sz="1575">
                 <a:solidFill>
                   <a:srgbClr val="1A1A1A"/>
@@ -3836,11 +3757,15 @@
                   <a:srgbClr val="1A1A1A"/>
                 </a:solidFill>
               </a:rPr>
-              <a:t>Built: an agent that chooses tools, attack tests, a detector and a recipient gate.</a:t>
+              <a:t>Built the agent, document search, contact lookup and simulated email, plus both defenses.</a:t>
             </a:r>
           </a:p>
           <a:p xmlns:a="http://schemas.openxmlformats.org/drawingml/2006/main">
-            <a:pPr>
+            <a:pPr marL="190500" indent="-101600">
+              <a:spcAft>
+                <a:spcPts val="800"/>
+              </a:spcAft>
+              <a:buChar char="•"/>
               <a:defRPr sz="1575">
                 <a:solidFill>
                   <a:srgbClr val="1A1A1A"/>
@@ -3853,114 +3778,15 @@
                   <a:srgbClr val="1A1A1A"/>
                 </a:solidFill>
               </a:rPr>
-              <a:t>Recent work: approval before protected live sends and a search startup fix.</a:t>
+              <a:t>Prepared 23 custom attacks and adapted 200 attacks from Microsoft’s LLMail-Inject dataset.</a:t>
             </a:r>
           </a:p>
-        </p:txBody>
-      </p:sp>
-      <p:sp>
-        <p:nvSpPr>
-          <p:cNvPr id="12" name="">
-            <a:extLst xmlns:a="http://schemas.openxmlformats.org/drawingml/2006/main">
-              <a:ext uri="{FF2B5EF4-FFF2-40B4-BE49-F238E27FC236}">
-                <a16:creationId xmlns:a16="http://schemas.microsoft.com/office/drawing/2014/main" id="{CFECC48F-DCC1-4B9A-9540-ABF20495E020}"/>
-              </a:ext>
-            </a:extLst>
-          </p:cNvPr>
-          <p:cNvSpPr>
-            <a:spLocks xmlns:a="http://schemas.openxmlformats.org/drawingml/2006/main" noGrp="1"/>
-          </p:cNvSpPr>
-          <p:nvPr/>
-        </p:nvSpPr>
-        <p:spPr>
-          <a:xfrm xmlns:a="http://schemas.openxmlformats.org/drawingml/2006/main">
-            <a:off x="960120" y="2771775"/>
-            <a:ext cx="10271474" cy="628650"/>
-          </a:xfrm>
-          <a:prstGeom xmlns:a="http://schemas.openxmlformats.org/drawingml/2006/main" prst="rect">
-            <a:avLst/>
-          </a:prstGeom>
-          <a:noFill xmlns:a="http://schemas.openxmlformats.org/drawingml/2006/main"/>
-          <a:ln xmlns:a="http://schemas.openxmlformats.org/drawingml/2006/main" w="0">
-            <a:noFill/>
-          </a:ln>
-        </p:spPr>
-        <p:txBody>
-          <a:bodyPr xmlns:a="http://schemas.openxmlformats.org/drawingml/2006/main" lIns="0" tIns="0" rIns="0" bIns="0"/>
-          <a:lstStyle xmlns:a="http://schemas.openxmlformats.org/drawingml/2006/main">
-            <a:defPPr>
-              <a:defRPr sz="1575">
-                <a:solidFill>
-                  <a:srgbClr val="1A1A1A"/>
-                </a:solidFill>
-              </a:defRPr>
-            </a:defPPr>
-            <a:lvl1pPr>
-              <a:defRPr sz="1575">
-                <a:solidFill>
-                  <a:srgbClr val="1A1A1A"/>
-                </a:solidFill>
-              </a:defRPr>
-            </a:lvl1pPr>
-            <a:lvl2pPr>
-              <a:defRPr sz="1575">
-                <a:solidFill>
-                  <a:srgbClr val="1A1A1A"/>
-                </a:solidFill>
-              </a:defRPr>
-            </a:lvl2pPr>
-            <a:lvl3pPr>
-              <a:defRPr sz="1575">
-                <a:solidFill>
-                  <a:srgbClr val="1A1A1A"/>
-                </a:solidFill>
-              </a:defRPr>
-            </a:lvl3pPr>
-            <a:lvl4pPr>
-              <a:defRPr sz="1575">
-                <a:solidFill>
-                  <a:srgbClr val="1A1A1A"/>
-                </a:solidFill>
-              </a:defRPr>
-            </a:lvl4pPr>
-            <a:lvl5pPr>
-              <a:defRPr sz="1575">
-                <a:solidFill>
-                  <a:srgbClr val="1A1A1A"/>
-                </a:solidFill>
-              </a:defRPr>
-            </a:lvl5pPr>
-            <a:lvl6pPr>
-              <a:defRPr sz="1575">
-                <a:solidFill>
-                  <a:srgbClr val="1A1A1A"/>
-                </a:solidFill>
-              </a:defRPr>
-            </a:lvl6pPr>
-            <a:lvl7pPr>
-              <a:defRPr sz="1575">
-                <a:solidFill>
-                  <a:srgbClr val="1A1A1A"/>
-                </a:solidFill>
-              </a:defRPr>
-            </a:lvl7pPr>
-            <a:lvl8pPr>
-              <a:defRPr sz="1575">
-                <a:solidFill>
-                  <a:srgbClr val="1A1A1A"/>
-                </a:solidFill>
-              </a:defRPr>
-            </a:lvl8pPr>
-            <a:lvl9pPr>
-              <a:defRPr sz="1575">
-                <a:solidFill>
-                  <a:srgbClr val="1A1A1A"/>
-                </a:solidFill>
-              </a:defRPr>
-            </a:lvl9pPr>
-          </a:lstStyle>
           <a:p xmlns:a="http://schemas.openxmlformats.org/drawingml/2006/main">
-            <a:pPr>
+            <a:pPr marL="190500" indent="-101600">
+              <a:spcAft>
+                <a:spcPts val="800"/>
+              </a:spcAft>
+              <a:buChar char="•"/>
               <a:defRPr sz="1575">
                 <a:solidFill>
                   <a:srgbClr val="1A1A1A"/>
@@ -3973,11 +3799,15 @@
                   <a:srgbClr val="1A1A1A"/>
                 </a:solidFill>
               </a:rPr>
-              <a:t>Data: 23 custom attacks + 200 adapted from Microsoft’s LLMail-Inject dataset.</a:t>
+              <a:t>All 256 software checks pass. The table uses 10 custom attacks and 7 normal tasks, 3 tries each.</a:t>
             </a:r>
           </a:p>
           <a:p xmlns:a="http://schemas.openxmlformats.org/drawingml/2006/main">
-            <a:pPr>
+            <a:pPr marL="190500" indent="-101600">
+              <a:spcAft>
+                <a:spcPts val="800"/>
+              </a:spcAft>
+              <a:buChar char="•"/>
               <a:defRPr sz="1575">
                 <a:solidFill>
                   <a:srgbClr val="1A1A1A"/>
@@ -3990,17 +3820,17 @@
                   <a:srgbClr val="1A1A1A"/>
                 </a:solidFill>
               </a:rPr>
-              <a:t>Checks: 256 software checks pass. Main experiment: 10 custom attacks, 3 tries each.</a:t>
+              <a:t>Added approval before protected live sends and fixed a search startup problem. Full live testing remains.</a:t>
             </a:r>
           </a:p>
         </p:txBody>
       </p:sp>
       <p:graphicFrame>
         <p:nvGraphicFramePr>
-          <p:cNvPr id="13" name="">
+          <p:cNvPr id="12" name="">
             <a:extLst xmlns:a="http://schemas.openxmlformats.org/drawingml/2006/main">
               <a:ext uri="{FF2B5EF4-FFF2-40B4-BE49-F238E27FC236}">
-                <a16:creationId xmlns:a16="http://schemas.microsoft.com/office/drawing/2014/main" id="{B5FC41C4-90E0-4520-9550-F69B7C8D1338}"/>
+                <a16:creationId xmlns:a16="http://schemas.microsoft.com/office/drawing/2014/main" id="{094241D4-5C5A-4DF6-AAF5-69538DD53F5D}"/>
               </a:ext>
             </a:extLst>
           </p:cNvPr>
@@ -4579,10 +4409,10 @@
       </p:graphicFrame>
       <p:sp>
         <p:nvSpPr>
-          <p:cNvPr id="14" name="">
+          <p:cNvPr id="13" name="">
             <a:extLst xmlns:a="http://schemas.openxmlformats.org/drawingml/2006/main">
               <a:ext uri="{FF2B5EF4-FFF2-40B4-BE49-F238E27FC236}">
-                <a16:creationId xmlns:a16="http://schemas.microsoft.com/office/drawing/2014/main" id="{806BA041-D84B-4B9A-874F-0BC37D55615E}"/>
+                <a16:creationId xmlns:a16="http://schemas.microsoft.com/office/drawing/2014/main" id="{F70B362E-9A19-4E4F-A43B-E1A56B4494A3}"/>
               </a:ext>
             </a:extLst>
           </p:cNvPr>
@@ -4717,7 +4547,7 @@
     </p:spTree>
     <p:extLst>
       <p:ext uri="{BB962C8B-B14F-4D97-AF65-F5344CB8AC3E}">
-        <p14:creationId xmlns:p14="http://schemas.microsoft.com/office/powerpoint/2010/main" val="1815527912"/>
+        <p14:creationId xmlns:p14="http://schemas.microsoft.com/office/powerpoint/2010/main" val="1911586050"/>
       </p:ext>
     </p:extLst>
   </p:cSld>
@@ -4748,7 +4578,7 @@
           <p:cNvPr id="2" name="Text 0">
             <a:extLst xmlns:a="http://schemas.openxmlformats.org/drawingml/2006/main">
               <a:ext uri="{FF2B5EF4-FFF2-40B4-BE49-F238E27FC236}">
-                <a16:creationId xmlns:a16="http://schemas.microsoft.com/office/drawing/2014/main" id="{0C8DCF2D-86F6-4EA2-A0E6-91788646830A}"/>
+                <a16:creationId xmlns:a16="http://schemas.microsoft.com/office/drawing/2014/main" id="{ED1E8A83-5071-47E9-8B05-DD9E04C12652}"/>
               </a:ext>
             </a:extLst>
           </p:cNvPr>
@@ -4794,7 +4624,7 @@
           <p:cNvPr id="3" name="Text 1">
             <a:extLst xmlns:a="http://schemas.openxmlformats.org/drawingml/2006/main">
               <a:ext uri="{FF2B5EF4-FFF2-40B4-BE49-F238E27FC236}">
-                <a16:creationId xmlns:a16="http://schemas.microsoft.com/office/drawing/2014/main" id="{6ACEA33B-0445-4D72-BEED-5A608BD51F28}"/>
+                <a16:creationId xmlns:a16="http://schemas.microsoft.com/office/drawing/2014/main" id="{FAABD296-6E0F-444F-8231-7D90113F5D83}"/>
               </a:ext>
             </a:extLst>
           </p:cNvPr>
@@ -4840,7 +4670,7 @@
           <p:cNvPr id="4" name="Text 2">
             <a:extLst xmlns:a="http://schemas.openxmlformats.org/drawingml/2006/main">
               <a:ext uri="{FF2B5EF4-FFF2-40B4-BE49-F238E27FC236}">
-                <a16:creationId xmlns:a16="http://schemas.microsoft.com/office/drawing/2014/main" id="{0BC99978-A4A7-4D5C-9009-EB538AE070DB}"/>
+                <a16:creationId xmlns:a16="http://schemas.microsoft.com/office/drawing/2014/main" id="{BFA9E32A-1E1C-4FD7-B396-65B7449D72AA}"/>
               </a:ext>
             </a:extLst>
           </p:cNvPr>
@@ -4886,7 +4716,7 @@
           <p:cNvPr id="5" name="Shape 3">
             <a:extLst xmlns:a="http://schemas.openxmlformats.org/drawingml/2006/main">
               <a:ext uri="{FF2B5EF4-FFF2-40B4-BE49-F238E27FC236}">
-                <a16:creationId xmlns:a16="http://schemas.microsoft.com/office/drawing/2014/main" id="{A83256B2-19DB-4E66-9C2A-2A222D7B7D85}"/>
+                <a16:creationId xmlns:a16="http://schemas.microsoft.com/office/drawing/2014/main" id="{A5D7013A-147A-4564-AD6B-CFAABF1F7D92}"/>
               </a:ext>
             </a:extLst>
           </p:cNvPr>
@@ -4913,7 +4743,7 @@
           <p:cNvPr id="6" name="Text 4">
             <a:extLst xmlns:a="http://schemas.openxmlformats.org/drawingml/2006/main">
               <a:ext uri="{FF2B5EF4-FFF2-40B4-BE49-F238E27FC236}">
-                <a16:creationId xmlns:a16="http://schemas.microsoft.com/office/drawing/2014/main" id="{1301D2A5-236A-4F59-805A-978C7FB97A7D}"/>
+                <a16:creationId xmlns:a16="http://schemas.microsoft.com/office/drawing/2014/main" id="{2BDC5881-A86E-4744-B2C9-3DE0F74C3D43}"/>
               </a:ext>
             </a:extLst>
           </p:cNvPr>
@@ -4948,7 +4778,7 @@
                 <a:ea typeface="Calibri"/>
                 <a:cs typeface="Calibri"/>
               </a:rPr>
-              <a:t>TARGETS AND LIMITATIONS</a:t>
+              <a:t>GOALS AND FINAL DEMONSTRATION</a:t>
             </a:r>
             <a:endParaRPr sz="1100"/>
           </a:p>
@@ -4959,7 +4789,7 @@
           <p:cNvPr id="9" name="Text 7">
             <a:extLst xmlns:a="http://schemas.openxmlformats.org/drawingml/2006/main">
               <a:ext uri="{FF2B5EF4-FFF2-40B4-BE49-F238E27FC236}">
-                <a16:creationId xmlns:a16="http://schemas.microsoft.com/office/drawing/2014/main" id="{53EEEDB1-74EA-4077-8219-68D9CA087E8E}"/>
+                <a16:creationId xmlns:a16="http://schemas.microsoft.com/office/drawing/2014/main" id="{70EBA831-2BE7-4DE6-9A4E-6F7607F78AB7}"/>
               </a:ext>
             </a:extLst>
           </p:cNvPr>
@@ -5005,7 +4835,7 @@
           <p:cNvPr id="10" name="Text 8">
             <a:extLst xmlns:a="http://schemas.openxmlformats.org/drawingml/2006/main">
               <a:ext uri="{FF2B5EF4-FFF2-40B4-BE49-F238E27FC236}">
-                <a16:creationId xmlns:a16="http://schemas.microsoft.com/office/drawing/2014/main" id="{AB5A9C4F-E110-40F5-931F-30C01721E001}"/>
+                <a16:creationId xmlns:a16="http://schemas.microsoft.com/office/drawing/2014/main" id="{EC4CE369-B777-4CB3-8AC6-7E90F852C5B7}"/>
               </a:ext>
             </a:extLst>
           </p:cNvPr>
@@ -5051,7 +4881,7 @@
           <p:cNvPr id="11" name="">
             <a:extLst xmlns:a="http://schemas.openxmlformats.org/drawingml/2006/main">
               <a:ext uri="{FF2B5EF4-FFF2-40B4-BE49-F238E27FC236}">
-                <a16:creationId xmlns:a16="http://schemas.microsoft.com/office/drawing/2014/main" id="{E1EC82FB-C717-41ED-90C2-A965366A4A53}"/>
+                <a16:creationId xmlns:a16="http://schemas.microsoft.com/office/drawing/2014/main" id="{F04D8DA5-D898-4CBA-B382-9558BCF4B498}"/>
               </a:ext>
             </a:extLst>
           </p:cNvPr>
@@ -5063,7 +4893,7 @@
         <p:spPr>
           <a:xfrm xmlns:a="http://schemas.openxmlformats.org/drawingml/2006/main">
             <a:off x="960120" y="2009775"/>
-            <a:ext cx="10271474" cy="704850"/>
+            <a:ext cx="10271474" cy="1714500"/>
           </a:xfrm>
           <a:prstGeom xmlns:a="http://schemas.openxmlformats.org/drawingml/2006/main" prst="rect">
             <a:avLst/>
@@ -5074,73 +4904,75 @@
           </a:ln>
         </p:spPr>
         <p:txBody>
-          <a:bodyPr xmlns:a="http://schemas.openxmlformats.org/drawingml/2006/main" lIns="0" tIns="0" rIns="0" bIns="0"/>
+          <a:bodyPr xmlns:a="http://schemas.openxmlformats.org/drawingml/2006/main" lIns="0" tIns="0" rIns="0" bIns="0">
+            <a:noAutofit/>
+          </a:bodyPr>
           <a:lstStyle xmlns:a="http://schemas.openxmlformats.org/drawingml/2006/main">
             <a:defPPr>
-              <a:defRPr sz="1725">
+              <a:defRPr sz="1575">
                 <a:solidFill>
                   <a:srgbClr val="1A1A1A"/>
                 </a:solidFill>
               </a:defRPr>
             </a:defPPr>
             <a:lvl1pPr>
-              <a:defRPr sz="1725">
+              <a:defRPr sz="1575">
                 <a:solidFill>
                   <a:srgbClr val="1A1A1A"/>
                 </a:solidFill>
               </a:defRPr>
             </a:lvl1pPr>
             <a:lvl2pPr>
-              <a:defRPr sz="1725">
+              <a:defRPr sz="1575">
                 <a:solidFill>
                   <a:srgbClr val="1A1A1A"/>
                 </a:solidFill>
               </a:defRPr>
             </a:lvl2pPr>
             <a:lvl3pPr>
-              <a:defRPr sz="1725">
+              <a:defRPr sz="1575">
                 <a:solidFill>
                   <a:srgbClr val="1A1A1A"/>
                 </a:solidFill>
               </a:defRPr>
             </a:lvl3pPr>
             <a:lvl4pPr>
-              <a:defRPr sz="1725">
+              <a:defRPr sz="1575">
                 <a:solidFill>
                   <a:srgbClr val="1A1A1A"/>
                 </a:solidFill>
               </a:defRPr>
             </a:lvl4pPr>
             <a:lvl5pPr>
-              <a:defRPr sz="1725">
+              <a:defRPr sz="1575">
                 <a:solidFill>
                   <a:srgbClr val="1A1A1A"/>
                 </a:solidFill>
               </a:defRPr>
             </a:lvl5pPr>
             <a:lvl6pPr>
-              <a:defRPr sz="1725">
+              <a:defRPr sz="1575">
                 <a:solidFill>
                   <a:srgbClr val="1A1A1A"/>
                 </a:solidFill>
               </a:defRPr>
             </a:lvl6pPr>
             <a:lvl7pPr>
-              <a:defRPr sz="1725">
+              <a:defRPr sz="1575">
                 <a:solidFill>
                   <a:srgbClr val="1A1A1A"/>
                 </a:solidFill>
               </a:defRPr>
             </a:lvl7pPr>
             <a:lvl8pPr>
-              <a:defRPr sz="1725">
+              <a:defRPr sz="1575">
                 <a:solidFill>
                   <a:srgbClr val="1A1A1A"/>
                 </a:solidFill>
               </a:defRPr>
             </a:lvl8pPr>
             <a:lvl9pPr>
-              <a:defRPr sz="1725">
+              <a:defRPr sz="1575">
                 <a:solidFill>
                   <a:srgbClr val="1A1A1A"/>
                 </a:solidFill>
@@ -5148,184 +4980,97 @@
             </a:lvl9pPr>
           </a:lstStyle>
           <a:p xmlns:a="http://schemas.openxmlformats.org/drawingml/2006/main">
-            <a:pPr>
-              <a:defRPr sz="1725">
+            <a:pPr marL="190500" indent="-101600">
+              <a:spcAft>
+                <a:spcPts val="800"/>
+              </a:spcAft>
+              <a:buChar char="•"/>
+              <a:defRPr sz="1575">
                 <a:solidFill>
                   <a:srgbClr val="1A1A1A"/>
                 </a:solidFill>
               </a:defRPr>
             </a:pPr>
             <a:r>
-              <a:rPr sz="1725">
+              <a:rPr sz="1575">
                 <a:solidFill>
                   <a:srgbClr val="1A1A1A"/>
                 </a:solidFill>
               </a:rPr>
-              <a:t>The goal stays the same: fewer attacker-directed actions while the agent</a:t>
+              <a:t>Our goal remains to reduce attacker control while keeping the agent useful for normal tasks.</a:t>
             </a:r>
           </a:p>
           <a:p xmlns:a="http://schemas.openxmlformats.org/drawingml/2006/main">
-            <a:pPr>
-              <a:defRPr sz="1725">
+            <a:pPr marL="190500" indent="-101600">
+              <a:spcAft>
+                <a:spcPts val="800"/>
+              </a:spcAft>
+              <a:buChar char="•"/>
+              <a:defRPr sz="1575">
                 <a:solidFill>
                   <a:srgbClr val="1A1A1A"/>
                 </a:solidFill>
               </a:defRPr>
             </a:pPr>
             <a:r>
-              <a:rPr sz="1725">
+              <a:rPr sz="1575">
                 <a:solidFill>
                   <a:srgbClr val="1A1A1A"/>
                 </a:solidFill>
               </a:rPr>
-              <a:t>continues to help the user. Email is our controlled test case.</a:t>
-            </a:r>
-          </a:p>
-        </p:txBody>
-      </p:sp>
-      <p:sp>
-        <p:nvSpPr>
-          <p:cNvPr id="12" name="">
-            <a:extLst xmlns:a="http://schemas.openxmlformats.org/drawingml/2006/main">
-              <a:ext uri="{FF2B5EF4-FFF2-40B4-BE49-F238E27FC236}">
-                <a16:creationId xmlns:a16="http://schemas.microsoft.com/office/drawing/2014/main" id="{563DC31C-BDA8-4869-A0CA-7D2D02224E5B}"/>
-              </a:ext>
-            </a:extLst>
-          </p:cNvPr>
-          <p:cNvSpPr>
-            <a:spLocks xmlns:a="http://schemas.openxmlformats.org/drawingml/2006/main" noGrp="1"/>
-          </p:cNvSpPr>
-          <p:nvPr/>
-        </p:nvSpPr>
-        <p:spPr>
-          <a:xfrm xmlns:a="http://schemas.openxmlformats.org/drawingml/2006/main">
-            <a:off x="960120" y="2895600"/>
-            <a:ext cx="10271474" cy="666750"/>
-          </a:xfrm>
-          <a:prstGeom xmlns:a="http://schemas.openxmlformats.org/drawingml/2006/main" prst="rect">
-            <a:avLst/>
-          </a:prstGeom>
-          <a:noFill xmlns:a="http://schemas.openxmlformats.org/drawingml/2006/main"/>
-          <a:ln xmlns:a="http://schemas.openxmlformats.org/drawingml/2006/main" w="0">
-            <a:noFill/>
-          </a:ln>
-        </p:spPr>
-        <p:txBody>
-          <a:bodyPr xmlns:a="http://schemas.openxmlformats.org/drawingml/2006/main" lIns="0" tIns="0" rIns="0" bIns="0"/>
-          <a:lstStyle xmlns:a="http://schemas.openxmlformats.org/drawingml/2006/main">
-            <a:defPPr>
-              <a:defRPr sz="1650">
-                <a:solidFill>
-                  <a:srgbClr val="1A1A1A"/>
-                </a:solidFill>
-              </a:defRPr>
-            </a:defPPr>
-            <a:lvl1pPr>
-              <a:defRPr sz="1650">
-                <a:solidFill>
-                  <a:srgbClr val="1A1A1A"/>
-                </a:solidFill>
-              </a:defRPr>
-            </a:lvl1pPr>
-            <a:lvl2pPr>
-              <a:defRPr sz="1650">
-                <a:solidFill>
-                  <a:srgbClr val="1A1A1A"/>
-                </a:solidFill>
-              </a:defRPr>
-            </a:lvl2pPr>
-            <a:lvl3pPr>
-              <a:defRPr sz="1650">
-                <a:solidFill>
-                  <a:srgbClr val="1A1A1A"/>
-                </a:solidFill>
-              </a:defRPr>
-            </a:lvl3pPr>
-            <a:lvl4pPr>
-              <a:defRPr sz="1650">
-                <a:solidFill>
-                  <a:srgbClr val="1A1A1A"/>
-                </a:solidFill>
-              </a:defRPr>
-            </a:lvl4pPr>
-            <a:lvl5pPr>
-              <a:defRPr sz="1650">
-                <a:solidFill>
-                  <a:srgbClr val="1A1A1A"/>
-                </a:solidFill>
-              </a:defRPr>
-            </a:lvl5pPr>
-            <a:lvl6pPr>
-              <a:defRPr sz="1650">
-                <a:solidFill>
-                  <a:srgbClr val="1A1A1A"/>
-                </a:solidFill>
-              </a:defRPr>
-            </a:lvl6pPr>
-            <a:lvl7pPr>
-              <a:defRPr sz="1650">
-                <a:solidFill>
-                  <a:srgbClr val="1A1A1A"/>
-                </a:solidFill>
-              </a:defRPr>
-            </a:lvl7pPr>
-            <a:lvl8pPr>
-              <a:defRPr sz="1650">
-                <a:solidFill>
-                  <a:srgbClr val="1A1A1A"/>
-                </a:solidFill>
-              </a:defRPr>
-            </a:lvl8pPr>
-            <a:lvl9pPr>
-              <a:defRPr sz="1650">
-                <a:solidFill>
-                  <a:srgbClr val="1A1A1A"/>
-                </a:solidFill>
-              </a:defRPr>
-            </a:lvl9pPr>
-          </a:lstStyle>
-          <a:p xmlns:a="http://schemas.openxmlformats.org/drawingml/2006/main">
-            <a:pPr>
-              <a:defRPr sz="1650">
-                <a:solidFill>
-                  <a:srgbClr val="1A1A1A"/>
-                </a:solidFill>
-              </a:defRPr>
-            </a:pPr>
-            <a:r>
-              <a:rPr sz="1650">
-                <a:solidFill>
-                  <a:srgbClr val="1A1A1A"/>
-                </a:solidFill>
-              </a:rPr>
-              <a:t>Our combined target is below 5% attack success. The current main result is 10%.</a:t>
+              <a:t>We aim for less than 5% attack success with both defenses. The early result is 10%.</a:t>
             </a:r>
           </a:p>
           <a:p xmlns:a="http://schemas.openxmlformats.org/drawingml/2006/main">
-            <a:pPr>
-              <a:defRPr sz="1650">
+            <a:pPr marL="190500" indent="-101600">
+              <a:spcAft>
+                <a:spcPts val="800"/>
+              </a:spcAft>
+              <a:buChar char="•"/>
+              <a:defRPr sz="1575">
                 <a:solidFill>
                   <a:srgbClr val="1A1A1A"/>
                 </a:solidFill>
               </a:defRPr>
             </a:pPr>
             <a:r>
-              <a:rPr sz="1650">
+              <a:rPr sz="1575">
                 <a:solidFill>
                   <a:srgbClr val="1A1A1A"/>
                 </a:solidFill>
               </a:rPr>
-              <a:t>The latest approval step still needs a full attack evaluation.</a:t>
+              <a:t>The final demo will compare the same document attack with and without defenses.</a:t>
+            </a:r>
+          </a:p>
+          <a:p xmlns:a="http://schemas.openxmlformats.org/drawingml/2006/main">
+            <a:pPr marL="190500" indent="-101600">
+              <a:spcAft>
+                <a:spcPts val="800"/>
+              </a:spcAft>
+              <a:buChar char="•"/>
+              <a:defRPr sz="1575">
+                <a:solidFill>
+                  <a:srgbClr val="1A1A1A"/>
+                </a:solidFill>
+              </a:defRPr>
+            </a:pPr>
+            <a:r>
+              <a:rPr sz="1575">
+                <a:solidFill>
+                  <a:srgbClr val="1A1A1A"/>
+                </a:solidFill>
+              </a:rPr>
+              <a:t>We added user approval for protected email sends. This adds human control and still needs attack testing.</a:t>
             </a:r>
           </a:p>
         </p:txBody>
       </p:sp>
       <p:graphicFrame>
         <p:nvGraphicFramePr>
-          <p:cNvPr id="13" name="">
+          <p:cNvPr id="12" name="">
             <a:extLst xmlns:a="http://schemas.openxmlformats.org/drawingml/2006/main">
               <a:ext uri="{FF2B5EF4-FFF2-40B4-BE49-F238E27FC236}">
-                <a16:creationId xmlns:a16="http://schemas.microsoft.com/office/drawing/2014/main" id="{B35B831E-4A21-4EE0-B040-B3EDB9F36CE8}"/>
+                <a16:creationId xmlns:a16="http://schemas.microsoft.com/office/drawing/2014/main" id="{62AB6655-1E6D-4600-A34E-4EDA32296181}"/>
               </a:ext>
             </a:extLst>
           </p:cNvPr>
@@ -5733,7 +5478,7 @@
     </p:spTree>
     <p:extLst>
       <p:ext uri="{BB962C8B-B14F-4D97-AF65-F5344CB8AC3E}">
-        <p14:creationId xmlns:p14="http://schemas.microsoft.com/office/powerpoint/2010/main" val="1765548270"/>
+        <p14:creationId xmlns:p14="http://schemas.microsoft.com/office/powerpoint/2010/main" val="1768087217"/>
       </p:ext>
     </p:extLst>
   </p:cSld>
@@ -5764,7 +5509,7 @@
           <p:cNvPr id="2" name="Text 0">
             <a:extLst xmlns:a="http://schemas.openxmlformats.org/drawingml/2006/main">
               <a:ext uri="{FF2B5EF4-FFF2-40B4-BE49-F238E27FC236}">
-                <a16:creationId xmlns:a16="http://schemas.microsoft.com/office/drawing/2014/main" id="{A4CD31EA-4110-4269-9353-E87A375270E6}"/>
+                <a16:creationId xmlns:a16="http://schemas.microsoft.com/office/drawing/2014/main" id="{6EB327EA-AE74-43DD-B4E3-FE1E1F2F06AA}"/>
               </a:ext>
             </a:extLst>
           </p:cNvPr>
@@ -5810,7 +5555,7 @@
           <p:cNvPr id="3" name="Text 1">
             <a:extLst xmlns:a="http://schemas.openxmlformats.org/drawingml/2006/main">
               <a:ext uri="{FF2B5EF4-FFF2-40B4-BE49-F238E27FC236}">
-                <a16:creationId xmlns:a16="http://schemas.microsoft.com/office/drawing/2014/main" id="{BEDEC444-822A-49B7-89FD-78607E2C726B}"/>
+                <a16:creationId xmlns:a16="http://schemas.microsoft.com/office/drawing/2014/main" id="{23941D9B-3262-4072-B042-CA11ED128E2D}"/>
               </a:ext>
             </a:extLst>
           </p:cNvPr>
@@ -5856,7 +5601,7 @@
           <p:cNvPr id="4" name="Text 2">
             <a:extLst xmlns:a="http://schemas.openxmlformats.org/drawingml/2006/main">
               <a:ext uri="{FF2B5EF4-FFF2-40B4-BE49-F238E27FC236}">
-                <a16:creationId xmlns:a16="http://schemas.microsoft.com/office/drawing/2014/main" id="{11821CE6-B82D-4C25-A5EB-4F338A661097}"/>
+                <a16:creationId xmlns:a16="http://schemas.microsoft.com/office/drawing/2014/main" id="{658F4FD1-C41F-4962-99D7-82A31EDE3B42}"/>
               </a:ext>
             </a:extLst>
           </p:cNvPr>
@@ -5902,7 +5647,7 @@
           <p:cNvPr id="5" name="Shape 3">
             <a:extLst xmlns:a="http://schemas.openxmlformats.org/drawingml/2006/main">
               <a:ext uri="{FF2B5EF4-FFF2-40B4-BE49-F238E27FC236}">
-                <a16:creationId xmlns:a16="http://schemas.microsoft.com/office/drawing/2014/main" id="{3B54EFC9-384A-4495-A8E1-A04A748F6C2F}"/>
+                <a16:creationId xmlns:a16="http://schemas.microsoft.com/office/drawing/2014/main" id="{EAD0ABD1-13FE-44C0-AA65-463C3102693A}"/>
               </a:ext>
             </a:extLst>
           </p:cNvPr>
@@ -5929,7 +5674,7 @@
           <p:cNvPr id="6" name="Text 4">
             <a:extLst xmlns:a="http://schemas.openxmlformats.org/drawingml/2006/main">
               <a:ext uri="{FF2B5EF4-FFF2-40B4-BE49-F238E27FC236}">
-                <a16:creationId xmlns:a16="http://schemas.microsoft.com/office/drawing/2014/main" id="{DCD31AFE-1B38-4272-A89B-E1EDC78A9CE9}"/>
+                <a16:creationId xmlns:a16="http://schemas.microsoft.com/office/drawing/2014/main" id="{4CEA5CED-F80B-4812-8793-7F91D297F553}"/>
               </a:ext>
             </a:extLst>
           </p:cNvPr>
@@ -5964,7 +5709,7 @@
                 <a:ea typeface="Calibri"/>
                 <a:cs typeface="Calibri"/>
               </a:rPr>
-              <a:t>REVISED PLAN</a:t>
+              <a:t>COMPLETED WORK AND NEXT STEPS</a:t>
             </a:r>
             <a:endParaRPr sz="1100"/>
           </a:p>
@@ -5975,7 +5720,7 @@
           <p:cNvPr id="11" name="Table 0">
             <a:extLst xmlns:a="http://schemas.openxmlformats.org/drawingml/2006/main">
               <a:ext uri="{FF2B5EF4-FFF2-40B4-BE49-F238E27FC236}">
-                <a16:creationId xmlns:a16="http://schemas.microsoft.com/office/drawing/2014/main" id="{398AC651-363B-460B-A126-C0940CD0D35E}"/>
+                <a16:creationId xmlns:a16="http://schemas.microsoft.com/office/drawing/2014/main" id="{DC5E5405-3AB9-4282-B4BE-42D93B36DB1E}"/>
               </a:ext>
             </a:extLst>
           </p:cNvPr>
@@ -7427,7 +7172,7 @@
           <p:cNvPr id="9" name="Text 6">
             <a:extLst xmlns:a="http://schemas.openxmlformats.org/drawingml/2006/main">
               <a:ext uri="{FF2B5EF4-FFF2-40B4-BE49-F238E27FC236}">
-                <a16:creationId xmlns:a16="http://schemas.microsoft.com/office/drawing/2014/main" id="{4D77B4A3-9196-44B3-B070-1814DAB92956}"/>
+                <a16:creationId xmlns:a16="http://schemas.microsoft.com/office/drawing/2014/main" id="{D8D03489-2F3B-4453-8561-D030811A720E}"/>
               </a:ext>
             </a:extLst>
           </p:cNvPr>
@@ -7473,7 +7218,7 @@
           <p:cNvPr id="10" name="Text 7">
             <a:extLst xmlns:a="http://schemas.openxmlformats.org/drawingml/2006/main">
               <a:ext uri="{FF2B5EF4-FFF2-40B4-BE49-F238E27FC236}">
-                <a16:creationId xmlns:a16="http://schemas.microsoft.com/office/drawing/2014/main" id="{F2B11FB7-F81B-4E1C-A044-8BF5126BCA53}"/>
+                <a16:creationId xmlns:a16="http://schemas.microsoft.com/office/drawing/2014/main" id="{96F8AE3D-63F4-4D4B-A09C-32AE7F673C16}"/>
               </a:ext>
             </a:extLst>
           </p:cNvPr>
@@ -7519,7 +7264,7 @@
           <p:cNvPr id="12" name="">
             <a:extLst xmlns:a="http://schemas.openxmlformats.org/drawingml/2006/main">
               <a:ext uri="{FF2B5EF4-FFF2-40B4-BE49-F238E27FC236}">
-                <a16:creationId xmlns:a16="http://schemas.microsoft.com/office/drawing/2014/main" id="{4728C76D-B732-4C7C-8E9A-AF3CD68D6076}"/>
+                <a16:creationId xmlns:a16="http://schemas.microsoft.com/office/drawing/2014/main" id="{B4E0C080-21BA-4C79-BE12-D7083435B59C}"/>
               </a:ext>
             </a:extLst>
           </p:cNvPr>
@@ -7531,7 +7276,7 @@
         <p:spPr>
           <a:xfrm xmlns:a="http://schemas.openxmlformats.org/drawingml/2006/main">
             <a:off x="960120" y="2009775"/>
-            <a:ext cx="10271474" cy="647700"/>
+            <a:ext cx="10271474" cy="1714500"/>
           </a:xfrm>
           <a:prstGeom xmlns:a="http://schemas.openxmlformats.org/drawingml/2006/main" prst="rect">
             <a:avLst/>
@@ -7542,73 +7287,75 @@
           </a:ln>
         </p:spPr>
         <p:txBody>
-          <a:bodyPr xmlns:a="http://schemas.openxmlformats.org/drawingml/2006/main" lIns="0" tIns="0" rIns="0" bIns="0"/>
+          <a:bodyPr xmlns:a="http://schemas.openxmlformats.org/drawingml/2006/main" lIns="0" tIns="0" rIns="0" bIns="0">
+            <a:noAutofit/>
+          </a:bodyPr>
           <a:lstStyle xmlns:a="http://schemas.openxmlformats.org/drawingml/2006/main">
             <a:defPPr>
-              <a:defRPr sz="1650">
+              <a:defRPr sz="1575">
                 <a:solidFill>
                   <a:srgbClr val="1A1A1A"/>
                 </a:solidFill>
               </a:defRPr>
             </a:defPPr>
             <a:lvl1pPr>
-              <a:defRPr sz="1650">
+              <a:defRPr sz="1575">
                 <a:solidFill>
                   <a:srgbClr val="1A1A1A"/>
                 </a:solidFill>
               </a:defRPr>
             </a:lvl1pPr>
             <a:lvl2pPr>
-              <a:defRPr sz="1650">
+              <a:defRPr sz="1575">
                 <a:solidFill>
                   <a:srgbClr val="1A1A1A"/>
                 </a:solidFill>
               </a:defRPr>
             </a:lvl2pPr>
             <a:lvl3pPr>
-              <a:defRPr sz="1650">
+              <a:defRPr sz="1575">
                 <a:solidFill>
                   <a:srgbClr val="1A1A1A"/>
                 </a:solidFill>
               </a:defRPr>
             </a:lvl3pPr>
             <a:lvl4pPr>
-              <a:defRPr sz="1650">
+              <a:defRPr sz="1575">
                 <a:solidFill>
                   <a:srgbClr val="1A1A1A"/>
                 </a:solidFill>
               </a:defRPr>
             </a:lvl4pPr>
             <a:lvl5pPr>
-              <a:defRPr sz="1650">
+              <a:defRPr sz="1575">
                 <a:solidFill>
                   <a:srgbClr val="1A1A1A"/>
                 </a:solidFill>
               </a:defRPr>
             </a:lvl5pPr>
             <a:lvl6pPr>
-              <a:defRPr sz="1650">
+              <a:defRPr sz="1575">
                 <a:solidFill>
                   <a:srgbClr val="1A1A1A"/>
                 </a:solidFill>
               </a:defRPr>
             </a:lvl6pPr>
             <a:lvl7pPr>
-              <a:defRPr sz="1650">
+              <a:defRPr sz="1575">
                 <a:solidFill>
                   <a:srgbClr val="1A1A1A"/>
                 </a:solidFill>
               </a:defRPr>
             </a:lvl7pPr>
             <a:lvl8pPr>
-              <a:defRPr sz="1650">
+              <a:defRPr sz="1575">
                 <a:solidFill>
                   <a:srgbClr val="1A1A1A"/>
                 </a:solidFill>
               </a:defRPr>
             </a:lvl8pPr>
             <a:lvl9pPr>
-              <a:defRPr sz="1650">
+              <a:defRPr sz="1575">
                 <a:solidFill>
                   <a:srgbClr val="1A1A1A"/>
                 </a:solidFill>
@@ -7616,144 +7363,32 @@
             </a:lvl9pPr>
           </a:lstStyle>
           <a:p xmlns:a="http://schemas.openxmlformats.org/drawingml/2006/main">
-            <a:pPr>
-              <a:defRPr sz="1650">
+            <a:pPr marL="190500" indent="-101600">
+              <a:spcAft>
+                <a:spcPts val="800"/>
+              </a:spcAft>
+              <a:buChar char="•"/>
+              <a:defRPr sz="1575">
                 <a:solidFill>
                   <a:srgbClr val="1A1A1A"/>
                 </a:solidFill>
               </a:defRPr>
             </a:pPr>
             <a:r>
-              <a:rPr sz="1650">
+              <a:rPr sz="1575">
                 <a:solidFill>
                   <a:srgbClr val="1A1A1A"/>
                 </a:solidFill>
               </a:rPr>
-              <a:t>Completed: the core agent, two defenses and preliminary experiments.</a:t>
+              <a:t>Completed the core agent, both defenses, attack collection and early experiments.</a:t>
             </a:r>
           </a:p>
           <a:p xmlns:a="http://schemas.openxmlformats.org/drawingml/2006/main">
-            <a:pPr>
-              <a:defRPr sz="1650">
-                <a:solidFill>
-                  <a:srgbClr val="1A1A1A"/>
-                </a:solidFill>
-              </a:defRPr>
-            </a:pPr>
-            <a:r>
-              <a:rPr sz="1650">
-                <a:solidFill>
-                  <a:srgbClr val="1A1A1A"/>
-                </a:solidFill>
-              </a:rPr>
-              <a:t>Added: live email approval and local reliability checks.</a:t>
-            </a:r>
-          </a:p>
-        </p:txBody>
-      </p:sp>
-      <p:sp>
-        <p:nvSpPr>
-          <p:cNvPr id="13" name="">
-            <a:extLst xmlns:a="http://schemas.openxmlformats.org/drawingml/2006/main">
-              <a:ext uri="{FF2B5EF4-FFF2-40B4-BE49-F238E27FC236}">
-                <a16:creationId xmlns:a16="http://schemas.microsoft.com/office/drawing/2014/main" id="{330BE829-43F9-4F41-9C21-132A92AEECDE}"/>
-              </a:ext>
-            </a:extLst>
-          </p:cNvPr>
-          <p:cNvSpPr>
-            <a:spLocks xmlns:a="http://schemas.openxmlformats.org/drawingml/2006/main" noGrp="1"/>
-          </p:cNvSpPr>
-          <p:nvPr/>
-        </p:nvSpPr>
-        <p:spPr>
-          <a:xfrm xmlns:a="http://schemas.openxmlformats.org/drawingml/2006/main">
-            <a:off x="960120" y="2857500"/>
-            <a:ext cx="10271474" cy="647700"/>
-          </a:xfrm>
-          <a:prstGeom xmlns:a="http://schemas.openxmlformats.org/drawingml/2006/main" prst="rect">
-            <a:avLst/>
-          </a:prstGeom>
-          <a:noFill xmlns:a="http://schemas.openxmlformats.org/drawingml/2006/main"/>
-          <a:ln xmlns:a="http://schemas.openxmlformats.org/drawingml/2006/main" w="0">
-            <a:noFill/>
-          </a:ln>
-        </p:spPr>
-        <p:txBody>
-          <a:bodyPr xmlns:a="http://schemas.openxmlformats.org/drawingml/2006/main" lIns="0" tIns="0" rIns="0" bIns="0"/>
-          <a:lstStyle xmlns:a="http://schemas.openxmlformats.org/drawingml/2006/main">
-            <a:defPPr>
-              <a:defRPr sz="1575">
-                <a:solidFill>
-                  <a:srgbClr val="1A1A1A"/>
-                </a:solidFill>
-              </a:defRPr>
-            </a:defPPr>
-            <a:lvl1pPr>
-              <a:defRPr sz="1575">
-                <a:solidFill>
-                  <a:srgbClr val="1A1A1A"/>
-                </a:solidFill>
-              </a:defRPr>
-            </a:lvl1pPr>
-            <a:lvl2pPr>
-              <a:defRPr sz="1575">
-                <a:solidFill>
-                  <a:srgbClr val="1A1A1A"/>
-                </a:solidFill>
-              </a:defRPr>
-            </a:lvl2pPr>
-            <a:lvl3pPr>
-              <a:defRPr sz="1575">
-                <a:solidFill>
-                  <a:srgbClr val="1A1A1A"/>
-                </a:solidFill>
-              </a:defRPr>
-            </a:lvl3pPr>
-            <a:lvl4pPr>
-              <a:defRPr sz="1575">
-                <a:solidFill>
-                  <a:srgbClr val="1A1A1A"/>
-                </a:solidFill>
-              </a:defRPr>
-            </a:lvl4pPr>
-            <a:lvl5pPr>
-              <a:defRPr sz="1575">
-                <a:solidFill>
-                  <a:srgbClr val="1A1A1A"/>
-                </a:solidFill>
-              </a:defRPr>
-            </a:lvl5pPr>
-            <a:lvl6pPr>
-              <a:defRPr sz="1575">
-                <a:solidFill>
-                  <a:srgbClr val="1A1A1A"/>
-                </a:solidFill>
-              </a:defRPr>
-            </a:lvl6pPr>
-            <a:lvl7pPr>
-              <a:defRPr sz="1575">
-                <a:solidFill>
-                  <a:srgbClr val="1A1A1A"/>
-                </a:solidFill>
-              </a:defRPr>
-            </a:lvl7pPr>
-            <a:lvl8pPr>
-              <a:defRPr sz="1575">
-                <a:solidFill>
-                  <a:srgbClr val="1A1A1A"/>
-                </a:solidFill>
-              </a:defRPr>
-            </a:lvl8pPr>
-            <a:lvl9pPr>
-              <a:defRPr sz="1575">
-                <a:solidFill>
-                  <a:srgbClr val="1A1A1A"/>
-                </a:solidFill>
-              </a:defRPr>
-            </a:lvl9pPr>
-          </a:lstStyle>
-          <a:p xmlns:a="http://schemas.openxmlformats.org/drawingml/2006/main">
-            <a:pPr>
+            <a:pPr marL="190500" indent="-101600">
+              <a:spcAft>
+                <a:spcPts val="800"/>
+              </a:spcAft>
+              <a:buChar char="•"/>
               <a:defRPr sz="1575">
                 <a:solidFill>
                   <a:srgbClr val="1A1A1A"/>
@@ -7766,11 +7401,15 @@
                   <a:srgbClr val="1A1A1A"/>
                 </a:solidFill>
               </a:rPr>
-              <a:t>Remaining: check hosted models, rehearse the demo and evaluate the final system.</a:t>
+              <a:t>Added email approval and checked it locally. We also fixed a document search startup problem.</a:t>
             </a:r>
           </a:p>
           <a:p xmlns:a="http://schemas.openxmlformats.org/drawingml/2006/main">
-            <a:pPr>
+            <a:pPr marL="190500" indent="-101600">
+              <a:spcAft>
+                <a:spcPts val="800"/>
+              </a:spcAft>
+              <a:buChar char="•"/>
               <a:defRPr sz="1575">
                 <a:solidFill>
                   <a:srgbClr val="1A1A1A"/>
@@ -7783,7 +7422,28 @@
                   <a:srgbClr val="1A1A1A"/>
                 </a:solidFill>
               </a:rPr>
-              <a:t>The dates below are team targets. Confirm the course’s Week 14 deadline.</a:t>
+              <a:t>Still pending: a fresh hosted-model check, a full demo rehearsal and final testing on examples kept aside.</a:t>
+            </a:r>
+          </a:p>
+          <a:p xmlns:a="http://schemas.openxmlformats.org/drawingml/2006/main">
+            <a:pPr marL="190500" indent="-101600">
+              <a:spcAft>
+                <a:spcPts val="800"/>
+              </a:spcAft>
+              <a:buChar char="•"/>
+              <a:defRPr sz="1575">
+                <a:solidFill>
+                  <a:srgbClr val="1A1A1A"/>
+                </a:solidFill>
+              </a:defRPr>
+            </a:pPr>
+            <a:r>
+              <a:rPr sz="1575">
+                <a:solidFill>
+                  <a:srgbClr val="1A1A1A"/>
+                </a:solidFill>
+              </a:rPr>
+              <a:t>The dates below are proposed team targets. Confirm the official Week 14 deadline with the instructor.</a:t>
             </a:r>
           </a:p>
         </p:txBody>
@@ -7791,7 +7451,7 @@
     </p:spTree>
     <p:extLst>
       <p:ext uri="{BB962C8B-B14F-4D97-AF65-F5344CB8AC3E}">
-        <p14:creationId xmlns:p14="http://schemas.microsoft.com/office/powerpoint/2010/main" val="1481086393"/>
+        <p14:creationId xmlns:p14="http://schemas.microsoft.com/office/powerpoint/2010/main" val="1729042174"/>
       </p:ext>
     </p:extLst>
   </p:cSld>

</xml_diff>